<commit_message>
Update course introduction and publications
</commit_message>
<xml_diff>
--- a/COMP2711/Materials/L00-Intro.pptx
+++ b/COMP2711/Materials/L00-Intro.pptx
@@ -5,7 +5,7 @@
     <p:sldMasterId id="2147483648" r:id="rId1"/>
   </p:sldMasterIdLst>
   <p:notesMasterIdLst>
-    <p:notesMasterId r:id="rId35"/>
+    <p:notesMasterId r:id="rId36"/>
   </p:notesMasterIdLst>
   <p:sldIdLst>
     <p:sldId id="811" r:id="rId2"/>
@@ -21,26 +21,27 @@
     <p:sldId id="1253" r:id="rId12"/>
     <p:sldId id="1254" r:id="rId13"/>
     <p:sldId id="1247" r:id="rId14"/>
-    <p:sldId id="1243" r:id="rId15"/>
-    <p:sldId id="1238" r:id="rId16"/>
-    <p:sldId id="1240" r:id="rId17"/>
-    <p:sldId id="1244" r:id="rId18"/>
-    <p:sldId id="1239" r:id="rId19"/>
-    <p:sldId id="1270" r:id="rId20"/>
-    <p:sldId id="1256" r:id="rId21"/>
-    <p:sldId id="1241" r:id="rId22"/>
-    <p:sldId id="1158" r:id="rId23"/>
-    <p:sldId id="1258" r:id="rId24"/>
-    <p:sldId id="1261" r:id="rId25"/>
-    <p:sldId id="1263" r:id="rId26"/>
-    <p:sldId id="1264" r:id="rId27"/>
-    <p:sldId id="1265" r:id="rId28"/>
-    <p:sldId id="1257" r:id="rId29"/>
-    <p:sldId id="1259" r:id="rId30"/>
-    <p:sldId id="1260" r:id="rId31"/>
-    <p:sldId id="1266" r:id="rId32"/>
-    <p:sldId id="1267" r:id="rId33"/>
-    <p:sldId id="1269" r:id="rId34"/>
+    <p:sldId id="1276" r:id="rId15"/>
+    <p:sldId id="1243" r:id="rId16"/>
+    <p:sldId id="1238" r:id="rId17"/>
+    <p:sldId id="1240" r:id="rId18"/>
+    <p:sldId id="1244" r:id="rId19"/>
+    <p:sldId id="1239" r:id="rId20"/>
+    <p:sldId id="1270" r:id="rId21"/>
+    <p:sldId id="1256" r:id="rId22"/>
+    <p:sldId id="1241" r:id="rId23"/>
+    <p:sldId id="1158" r:id="rId24"/>
+    <p:sldId id="1258" r:id="rId25"/>
+    <p:sldId id="1261" r:id="rId26"/>
+    <p:sldId id="1263" r:id="rId27"/>
+    <p:sldId id="1264" r:id="rId28"/>
+    <p:sldId id="1265" r:id="rId29"/>
+    <p:sldId id="1257" r:id="rId30"/>
+    <p:sldId id="1259" r:id="rId31"/>
+    <p:sldId id="1260" r:id="rId32"/>
+    <p:sldId id="1266" r:id="rId33"/>
+    <p:sldId id="1267" r:id="rId34"/>
+    <p:sldId id="1269" r:id="rId35"/>
   </p:sldIdLst>
   <p:sldSz cx="12192000" cy="6858000"/>
   <p:notesSz cx="6858000" cy="9144000"/>
@@ -229,7 +230,7 @@
           <a:p>
             <a:fld id="{25C994D2-5E16-4D9C-AEFB-2A261088A902}" type="datetimeFigureOut">
               <a:rPr lang="zh-CN" altLang="en-US" smtClean="0"/>
-              <a:t>2026/9/1</a:t>
+              <a:t>2026/9/15</a:t>
             </a:fld>
             <a:endParaRPr lang="zh-CN" altLang="en-US"/>
           </a:p>
@@ -659,7 +660,7 @@
           <a:p>
             <a:fld id="{124B687B-81D5-4F44-AE6B-34CD1245FD04}" type="slidenum">
               <a:rPr lang="zh-CN" altLang="en-US" smtClean="0"/>
-              <a:t>16</a:t>
+              <a:t>17</a:t>
             </a:fld>
             <a:endParaRPr lang="zh-CN" altLang="en-US"/>
           </a:p>
@@ -743,7 +744,7 @@
           <a:p>
             <a:fld id="{124B687B-81D5-4F44-AE6B-34CD1245FD04}" type="slidenum">
               <a:rPr lang="zh-CN" altLang="en-US" smtClean="0"/>
-              <a:t>17</a:t>
+              <a:t>18</a:t>
             </a:fld>
             <a:endParaRPr lang="zh-CN" altLang="en-US"/>
           </a:p>
@@ -851,7 +852,7 @@
           <a:p>
             <a:fld id="{124B687B-81D5-4F44-AE6B-34CD1245FD04}" type="slidenum">
               <a:rPr lang="zh-CN" altLang="en-US" smtClean="0"/>
-              <a:t>21</a:t>
+              <a:t>22</a:t>
             </a:fld>
             <a:endParaRPr lang="zh-CN" altLang="en-US"/>
           </a:p>
@@ -935,7 +936,7 @@
           <a:p>
             <a:fld id="{124B687B-81D5-4F44-AE6B-34CD1245FD04}" type="slidenum">
               <a:rPr lang="zh-CN" altLang="en-US" smtClean="0"/>
-              <a:t>22</a:t>
+              <a:t>23</a:t>
             </a:fld>
             <a:endParaRPr lang="zh-CN" altLang="en-US"/>
           </a:p>
@@ -1014,7 +1015,7 @@
           <a:p>
             <a:fld id="{124B687B-81D5-4F44-AE6B-34CD1245FD04}" type="slidenum">
               <a:rPr lang="zh-CN" altLang="en-US" smtClean="0"/>
-              <a:t>30</a:t>
+              <a:t>31</a:t>
             </a:fld>
             <a:endParaRPr lang="zh-CN" altLang="en-US"/>
           </a:p>
@@ -1698,7 +1699,7 @@
           <a:p>
             <a:fld id="{124B687B-81D5-4F44-AE6B-34CD1245FD04}" type="slidenum">
               <a:rPr lang="zh-CN" altLang="en-US" smtClean="0"/>
-              <a:t>14</a:t>
+              <a:t>15</a:t>
             </a:fld>
             <a:endParaRPr lang="zh-CN" altLang="en-US"/>
           </a:p>
@@ -1806,7 +1807,7 @@
           <a:p>
             <a:fld id="{124B687B-81D5-4F44-AE6B-34CD1245FD04}" type="slidenum">
               <a:rPr lang="zh-CN" altLang="en-US" smtClean="0"/>
-              <a:t>15</a:t>
+              <a:t>16</a:t>
             </a:fld>
             <a:endParaRPr lang="zh-CN" altLang="en-US"/>
           </a:p>
@@ -1954,7 +1955,7 @@
           <a:p>
             <a:fld id="{B55539BE-7814-4F40-9B13-ED058F5296F6}" type="datetime1">
               <a:rPr lang="en-US" altLang="zh-CN" smtClean="0"/>
-              <a:t>9/1/26</a:t>
+              <a:t>9/15/26</a:t>
             </a:fld>
             <a:endParaRPr lang="zh-CN" altLang="en-US"/>
           </a:p>
@@ -2117,7 +2118,7 @@
           <a:p>
             <a:fld id="{EEAFED07-9D19-3E4F-BFBB-DBA043D25E28}" type="datetime1">
               <a:rPr lang="en-US" altLang="zh-CN" smtClean="0"/>
-              <a:t>9/1/26</a:t>
+              <a:t>9/15/26</a:t>
             </a:fld>
             <a:endParaRPr lang="zh-CN" altLang="en-US"/>
           </a:p>
@@ -2290,7 +2291,7 @@
           <a:p>
             <a:fld id="{67330EEB-C08B-094A-93F5-FA783B6F7AB4}" type="datetime1">
               <a:rPr lang="en-US" altLang="zh-CN" smtClean="0"/>
-              <a:t>9/1/26</a:t>
+              <a:t>9/15/26</a:t>
             </a:fld>
             <a:endParaRPr lang="zh-CN" altLang="en-US"/>
           </a:p>
@@ -2453,7 +2454,7 @@
           <a:p>
             <a:fld id="{AEB879E7-7309-B744-8508-55BA062823BA}" type="datetime1">
               <a:rPr lang="en-US" altLang="zh-CN" smtClean="0"/>
-              <a:t>9/1/26</a:t>
+              <a:t>9/15/26</a:t>
             </a:fld>
             <a:endParaRPr lang="zh-CN" altLang="en-US"/>
           </a:p>
@@ -2693,7 +2694,7 @@
           <a:p>
             <a:fld id="{18A38E8C-83BF-0343-BA9D-CD8934766BEE}" type="datetime1">
               <a:rPr lang="en-US" altLang="zh-CN" smtClean="0"/>
-              <a:t>9/1/26</a:t>
+              <a:t>9/15/26</a:t>
             </a:fld>
             <a:endParaRPr lang="zh-CN" altLang="en-US"/>
           </a:p>
@@ -2917,7 +2918,7 @@
           <a:p>
             <a:fld id="{0D39572B-CB40-274D-8E20-0E4CAD31D592}" type="datetime1">
               <a:rPr lang="en-US" altLang="zh-CN" smtClean="0"/>
-              <a:t>9/1/26</a:t>
+              <a:t>9/15/26</a:t>
             </a:fld>
             <a:endParaRPr lang="zh-CN" altLang="en-US"/>
           </a:p>
@@ -3276,7 +3277,7 @@
           <a:p>
             <a:fld id="{24D5FE47-B48D-7047-923A-F9E5E9AACF6E}" type="datetime1">
               <a:rPr lang="en-US" altLang="zh-CN" smtClean="0"/>
-              <a:t>9/1/26</a:t>
+              <a:t>9/15/26</a:t>
             </a:fld>
             <a:endParaRPr lang="zh-CN" altLang="en-US"/>
           </a:p>
@@ -3388,7 +3389,7 @@
           <a:p>
             <a:fld id="{4A3127E9-7423-514E-8A91-6221CF408F22}" type="datetime1">
               <a:rPr lang="en-US" altLang="zh-CN" smtClean="0"/>
-              <a:t>9/1/26</a:t>
+              <a:t>9/15/26</a:t>
             </a:fld>
             <a:endParaRPr lang="zh-CN" altLang="en-US"/>
           </a:p>
@@ -3478,7 +3479,7 @@
           <a:p>
             <a:fld id="{D472ECE4-6FD7-4C49-ACA7-0491F2AA5E06}" type="datetime1">
               <a:rPr lang="en-US" altLang="zh-CN" smtClean="0"/>
-              <a:t>9/1/26</a:t>
+              <a:t>9/15/26</a:t>
             </a:fld>
             <a:endParaRPr lang="zh-CN" altLang="en-US"/>
           </a:p>
@@ -3748,7 +3749,7 @@
           <a:p>
             <a:fld id="{38B8077B-E76B-4B41-B17F-19AC0FC832B3}" type="datetime1">
               <a:rPr lang="en-US" altLang="zh-CN" smtClean="0"/>
-              <a:t>9/1/26</a:t>
+              <a:t>9/15/26</a:t>
             </a:fld>
             <a:endParaRPr lang="zh-CN" altLang="en-US"/>
           </a:p>
@@ -3995,7 +3996,7 @@
           <a:p>
             <a:fld id="{9EB24C7A-7D1C-8740-9D15-AD14720A28F9}" type="datetime1">
               <a:rPr lang="en-US" altLang="zh-CN" smtClean="0"/>
-              <a:t>9/1/26</a:t>
+              <a:t>9/15/26</a:t>
             </a:fld>
             <a:endParaRPr lang="zh-CN" altLang="en-US"/>
           </a:p>
@@ -4204,7 +4205,7 @@
           <a:p>
             <a:fld id="{9F63DA8F-0F2F-984A-A18D-D21C38A7121B}" type="datetime1">
               <a:rPr lang="en-US" altLang="zh-CN" smtClean="0"/>
-              <a:t>9/1/26</a:t>
+              <a:t>9/15/26</a:t>
             </a:fld>
             <a:endParaRPr lang="zh-CN" altLang="en-US"/>
           </a:p>
@@ -6296,6 +6297,180 @@
   <p:cSld>
     <p:spTree>
       <p:nvGrpSpPr>
+        <p:cNvPr id="1" name=""/>
+        <p:cNvGrpSpPr/>
+        <p:nvPr/>
+      </p:nvGrpSpPr>
+      <p:grpSpPr>
+        <a:xfrm>
+          <a:off x="0" y="0"/>
+          <a:ext cx="0" cy="0"/>
+          <a:chOff x="0" y="0"/>
+          <a:chExt cx="0" cy="0"/>
+        </a:xfrm>
+      </p:grpSpPr>
+      <p:sp>
+        <p:nvSpPr>
+          <p:cNvPr id="2" name="Title 1">
+            <a:extLst>
+              <a:ext uri="{FF2B5EF4-FFF2-40B4-BE49-F238E27FC236}">
+                <a16:creationId xmlns:a16="http://schemas.microsoft.com/office/drawing/2014/main" id="{1F8D5597-C169-FB56-639E-9B736A2B1562}"/>
+              </a:ext>
+            </a:extLst>
+          </p:cNvPr>
+          <p:cNvSpPr>
+            <a:spLocks noGrp="1"/>
+          </p:cNvSpPr>
+          <p:nvPr>
+            <p:ph type="title"/>
+          </p:nvPr>
+        </p:nvSpPr>
+        <p:spPr/>
+        <p:txBody>
+          <a:bodyPr/>
+          <a:lstStyle/>
+          <a:p>
+            <a:r>
+              <a:rPr lang="en-US" dirty="0"/>
+              <a:t>Annoucement</a:t>
+            </a:r>
+          </a:p>
+        </p:txBody>
+      </p:sp>
+      <p:sp>
+        <p:nvSpPr>
+          <p:cNvPr id="3" name="Content Placeholder 2">
+            <a:extLst>
+              <a:ext uri="{FF2B5EF4-FFF2-40B4-BE49-F238E27FC236}">
+                <a16:creationId xmlns:a16="http://schemas.microsoft.com/office/drawing/2014/main" id="{093DBFD3-667D-49DE-A175-F15A57183EC2}"/>
+              </a:ext>
+            </a:extLst>
+          </p:cNvPr>
+          <p:cNvSpPr>
+            <a:spLocks noGrp="1"/>
+          </p:cNvSpPr>
+          <p:nvPr>
+            <p:ph idx="1"/>
+          </p:nvPr>
+        </p:nvSpPr>
+        <p:spPr/>
+        <p:txBody>
+          <a:bodyPr/>
+          <a:lstStyle/>
+          <a:p>
+            <a:r>
+              <a:rPr lang="en-US" dirty="0">
+                <a:solidFill>
+                  <a:srgbClr val="FF0000"/>
+                </a:solidFill>
+              </a:rPr>
+              <a:t>HW1: releasing this weekend</a:t>
+            </a:r>
+          </a:p>
+          <a:p>
+            <a:endParaRPr lang="en-US" dirty="0"/>
+          </a:p>
+          <a:p>
+            <a:endParaRPr lang="en-US" dirty="0"/>
+          </a:p>
+          <a:p>
+            <a:r>
+              <a:rPr lang="en-US" sz="3600" b="1" dirty="0">
+                <a:solidFill>
+                  <a:srgbClr val="FF0000"/>
+                </a:solidFill>
+              </a:rPr>
+              <a:t>Classroom change</a:t>
+            </a:r>
+            <a:r>
+              <a:rPr lang="en-US" sz="3600" b="1">
+                <a:solidFill>
+                  <a:srgbClr val="FF0000"/>
+                </a:solidFill>
+              </a:rPr>
+              <a:t>: </a:t>
+            </a:r>
+          </a:p>
+          <a:p>
+            <a:r>
+              <a:rPr lang="en-US" sz="3600" b="1">
+                <a:solidFill>
+                  <a:srgbClr val="FF0000"/>
+                </a:solidFill>
+              </a:rPr>
+              <a:t>Rm </a:t>
+            </a:r>
+            <a:r>
+              <a:rPr lang="en-US" sz="3600" b="1" dirty="0">
+                <a:solidFill>
+                  <a:srgbClr val="FF0000"/>
+                </a:solidFill>
+              </a:rPr>
+              <a:t>5403 starting next week (until the end of </a:t>
+            </a:r>
+            <a:r>
+              <a:rPr lang="en-US" sz="3600" b="1">
+                <a:solidFill>
+                  <a:srgbClr val="FF0000"/>
+                </a:solidFill>
+              </a:rPr>
+              <a:t>the semester!)</a:t>
+            </a:r>
+            <a:endParaRPr lang="en-US" sz="3600" b="1" dirty="0">
+              <a:solidFill>
+                <a:srgbClr val="FF0000"/>
+              </a:solidFill>
+            </a:endParaRPr>
+          </a:p>
+        </p:txBody>
+      </p:sp>
+      <p:sp>
+        <p:nvSpPr>
+          <p:cNvPr id="4" name="Slide Number Placeholder 3">
+            <a:extLst>
+              <a:ext uri="{FF2B5EF4-FFF2-40B4-BE49-F238E27FC236}">
+                <a16:creationId xmlns:a16="http://schemas.microsoft.com/office/drawing/2014/main" id="{0B627DE2-639A-770C-E533-F1953F660147}"/>
+              </a:ext>
+            </a:extLst>
+          </p:cNvPr>
+          <p:cNvSpPr>
+            <a:spLocks noGrp="1"/>
+          </p:cNvSpPr>
+          <p:nvPr>
+            <p:ph type="sldNum" sz="quarter" idx="12"/>
+          </p:nvPr>
+        </p:nvSpPr>
+        <p:spPr/>
+        <p:txBody>
+          <a:bodyPr/>
+          <a:lstStyle/>
+          <a:p>
+            <a:fld id="{8B4C9E33-6753-472F-9C09-83153B974C9D}" type="slidenum">
+              <a:rPr lang="zh-CN" altLang="en-US" smtClean="0"/>
+              <a:t>14</a:t>
+            </a:fld>
+            <a:endParaRPr lang="zh-CN" altLang="en-US"/>
+          </a:p>
+        </p:txBody>
+      </p:sp>
+    </p:spTree>
+    <p:extLst>
+      <p:ext uri="{BB962C8B-B14F-4D97-AF65-F5344CB8AC3E}">
+        <p14:creationId xmlns:p14="http://schemas.microsoft.com/office/powerpoint/2010/main" val="3468220662"/>
+      </p:ext>
+    </p:extLst>
+  </p:cSld>
+  <p:clrMapOvr>
+    <a:masterClrMapping/>
+  </p:clrMapOvr>
+</p:sld>
+</file>
+
+<file path=ppt/slides/slide15.xml><?xml version="1.0" encoding="utf-8"?>
+<p:sld xmlns:a="http://schemas.openxmlformats.org/drawingml/2006/main" xmlns:r="http://schemas.openxmlformats.org/officeDocument/2006/relationships" xmlns:p="http://schemas.openxmlformats.org/presentationml/2006/main">
+  <p:cSld>
+    <p:spTree>
+      <p:nvGrpSpPr>
         <p:cNvPr id="1" name="">
           <a:extLst>
             <a:ext uri="{FF2B5EF4-FFF2-40B4-BE49-F238E27FC236}">
@@ -6468,7 +6643,7 @@
           <a:p>
             <a:fld id="{8B4C9E33-6753-472F-9C09-83153B974C9D}" type="slidenum">
               <a:rPr lang="zh-CN" altLang="en-US" smtClean="0"/>
-              <a:t>14</a:t>
+              <a:t>15</a:t>
             </a:fld>
             <a:endParaRPr lang="zh-CN" altLang="en-US"/>
           </a:p>
@@ -6487,7 +6662,7 @@
 </p:sld>
 </file>
 
-<file path=ppt/slides/slide15.xml><?xml version="1.0" encoding="utf-8"?>
+<file path=ppt/slides/slide16.xml><?xml version="1.0" encoding="utf-8"?>
 <p:sld xmlns:a="http://schemas.openxmlformats.org/drawingml/2006/main" xmlns:r="http://schemas.openxmlformats.org/officeDocument/2006/relationships" xmlns:p="http://schemas.openxmlformats.org/presentationml/2006/main">
   <p:cSld>
     <p:spTree>
@@ -6763,7 +6938,7 @@
                 <a:latin typeface="Calibri" panose="020F0502020204030204" pitchFamily="34" charset="0"/>
                 <a:cs typeface="Calibri" panose="020F0502020204030204" pitchFamily="34" charset="0"/>
               </a:rPr>
-              <a:t>15</a:t>
+              <a:t>16</a:t>
             </a:fld>
             <a:endParaRPr lang="zh-CN" altLang="en-US">
               <a:latin typeface="Calibri" panose="020F0502020204030204" pitchFamily="34" charset="0"/>
@@ -6785,7 +6960,7 @@
 </p:sld>
 </file>
 
-<file path=ppt/slides/slide16.xml><?xml version="1.0" encoding="utf-8"?>
+<file path=ppt/slides/slide17.xml><?xml version="1.0" encoding="utf-8"?>
 <p:sld xmlns:a="http://schemas.openxmlformats.org/drawingml/2006/main" xmlns:r="http://schemas.openxmlformats.org/officeDocument/2006/relationships" xmlns:p="http://schemas.openxmlformats.org/presentationml/2006/main">
   <p:cSld>
     <p:spTree>
@@ -7050,7 +7225,7 @@
                 <a:latin typeface="Calibri" panose="020F0502020204030204" pitchFamily="34" charset="0"/>
                 <a:cs typeface="Calibri" panose="020F0502020204030204" pitchFamily="34" charset="0"/>
               </a:rPr>
-              <a:t>16</a:t>
+              <a:t>17</a:t>
             </a:fld>
             <a:endParaRPr lang="zh-CN" altLang="en-US">
               <a:latin typeface="Calibri" panose="020F0502020204030204" pitchFamily="34" charset="0"/>
@@ -7063,206 +7238,6 @@
     <p:extLst>
       <p:ext uri="{BB962C8B-B14F-4D97-AF65-F5344CB8AC3E}">
         <p14:creationId xmlns:p14="http://schemas.microsoft.com/office/powerpoint/2010/main" val="1222288333"/>
-      </p:ext>
-    </p:extLst>
-  </p:cSld>
-  <p:clrMapOvr>
-    <a:masterClrMapping/>
-  </p:clrMapOvr>
-</p:sld>
-</file>
-
-<file path=ppt/slides/slide17.xml><?xml version="1.0" encoding="utf-8"?>
-<p:sld xmlns:a="http://schemas.openxmlformats.org/drawingml/2006/main" xmlns:r="http://schemas.openxmlformats.org/officeDocument/2006/relationships" xmlns:p="http://schemas.openxmlformats.org/presentationml/2006/main">
-  <p:cSld>
-    <p:spTree>
-      <p:nvGrpSpPr>
-        <p:cNvPr id="1" name=""/>
-        <p:cNvGrpSpPr/>
-        <p:nvPr/>
-      </p:nvGrpSpPr>
-      <p:grpSpPr>
-        <a:xfrm>
-          <a:off x="0" y="0"/>
-          <a:ext cx="0" cy="0"/>
-          <a:chOff x="0" y="0"/>
-          <a:chExt cx="0" cy="0"/>
-        </a:xfrm>
-      </p:grpSpPr>
-      <p:sp>
-        <p:nvSpPr>
-          <p:cNvPr id="2" name="Title 1">
-            <a:extLst>
-              <a:ext uri="{FF2B5EF4-FFF2-40B4-BE49-F238E27FC236}">
-                <a16:creationId xmlns:a16="http://schemas.microsoft.com/office/drawing/2014/main" id="{0C66574F-C5FA-24F5-C088-18CF635CF786}"/>
-              </a:ext>
-            </a:extLst>
-          </p:cNvPr>
-          <p:cNvSpPr>
-            <a:spLocks noGrp="1"/>
-          </p:cNvSpPr>
-          <p:nvPr>
-            <p:ph type="title"/>
-          </p:nvPr>
-        </p:nvSpPr>
-        <p:spPr/>
-        <p:txBody>
-          <a:bodyPr/>
-          <a:lstStyle/>
-          <a:p>
-            <a:r>
-              <a:rPr lang="en-US" b="1" dirty="0">
-                <a:latin typeface="Calibri" panose="020F0502020204030204" pitchFamily="34" charset="0"/>
-                <a:cs typeface="Calibri" panose="020F0502020204030204" pitchFamily="34" charset="0"/>
-              </a:rPr>
-              <a:t>Communication</a:t>
-            </a:r>
-            <a:endParaRPr lang="en-US" dirty="0"/>
-          </a:p>
-        </p:txBody>
-      </p:sp>
-      <p:sp>
-        <p:nvSpPr>
-          <p:cNvPr id="3" name="Content Placeholder 2">
-            <a:extLst>
-              <a:ext uri="{FF2B5EF4-FFF2-40B4-BE49-F238E27FC236}">
-                <a16:creationId xmlns:a16="http://schemas.microsoft.com/office/drawing/2014/main" id="{56935A31-7449-1ADD-AECB-730CD85BAC86}"/>
-              </a:ext>
-            </a:extLst>
-          </p:cNvPr>
-          <p:cNvSpPr>
-            <a:spLocks noGrp="1"/>
-          </p:cNvSpPr>
-          <p:nvPr>
-            <p:ph idx="1"/>
-          </p:nvPr>
-        </p:nvSpPr>
-        <p:spPr/>
-        <p:txBody>
-          <a:bodyPr>
-            <a:normAutofit fontScale="92500" lnSpcReduction="20000"/>
-          </a:bodyPr>
-          <a:lstStyle/>
-          <a:p>
-            <a:r>
-              <a:rPr lang="en-US" sz="3600" b="1" dirty="0">
-                <a:latin typeface="Calibri" panose="020F0502020204030204" pitchFamily="34" charset="0"/>
-                <a:cs typeface="Calibri" panose="020F0502020204030204" pitchFamily="34" charset="0"/>
-              </a:rPr>
-              <a:t>Daily</a:t>
-            </a:r>
-          </a:p>
-          <a:p>
-            <a:pPr lvl="1"/>
-            <a:r>
-              <a:rPr lang="en-US" sz="3200" dirty="0">
-                <a:latin typeface="Calibri" panose="020F0502020204030204" pitchFamily="34" charset="0"/>
-                <a:cs typeface="Calibri" panose="020F0502020204030204" pitchFamily="34" charset="0"/>
-              </a:rPr>
-              <a:t>Q&amp;A sessions</a:t>
-            </a:r>
-          </a:p>
-          <a:p>
-            <a:pPr lvl="1"/>
-            <a:r>
-              <a:rPr lang="en-US" sz="3200" dirty="0">
-                <a:latin typeface="Calibri" panose="020F0502020204030204" pitchFamily="34" charset="0"/>
-                <a:cs typeface="Calibri" panose="020F0502020204030204" pitchFamily="34" charset="0"/>
-              </a:rPr>
-              <a:t>Canvas - Announcement</a:t>
-            </a:r>
-          </a:p>
-          <a:p>
-            <a:pPr lvl="1"/>
-            <a:r>
-              <a:rPr lang="en-US" sz="3200" dirty="0">
-                <a:latin typeface="Calibri" panose="020F0502020204030204" pitchFamily="34" charset="0"/>
-                <a:cs typeface="Calibri" panose="020F0502020204030204" pitchFamily="34" charset="0"/>
-              </a:rPr>
-              <a:t>Canvas – Discussion</a:t>
-            </a:r>
-          </a:p>
-          <a:p>
-            <a:pPr lvl="1"/>
-            <a:r>
-              <a:rPr lang="en-US" sz="3200" dirty="0">
-                <a:latin typeface="Calibri" panose="020F0502020204030204" pitchFamily="34" charset="0"/>
-                <a:cs typeface="Calibri" panose="020F0502020204030204" pitchFamily="34" charset="0"/>
-              </a:rPr>
-              <a:t>Telegram group (links on canvas)</a:t>
-            </a:r>
-          </a:p>
-          <a:p>
-            <a:pPr lvl="1"/>
-            <a:endParaRPr lang="en-US" sz="3200" dirty="0">
-              <a:latin typeface="Calibri" panose="020F0502020204030204" pitchFamily="34" charset="0"/>
-              <a:cs typeface="Calibri" panose="020F0502020204030204" pitchFamily="34" charset="0"/>
-            </a:endParaRPr>
-          </a:p>
-          <a:p>
-            <a:r>
-              <a:rPr lang="en-US" sz="3600" b="1" dirty="0">
-                <a:latin typeface="Calibri" panose="020F0502020204030204" pitchFamily="34" charset="0"/>
-                <a:cs typeface="Calibri" panose="020F0502020204030204" pitchFamily="34" charset="0"/>
-              </a:rPr>
-              <a:t>Urgent</a:t>
-            </a:r>
-          </a:p>
-          <a:p>
-            <a:pPr lvl="1"/>
-            <a:r>
-              <a:rPr lang="en-US" sz="3200" dirty="0">
-                <a:latin typeface="Calibri" panose="020F0502020204030204" pitchFamily="34" charset="0"/>
-                <a:cs typeface="Calibri" panose="020F0502020204030204" pitchFamily="34" charset="0"/>
-              </a:rPr>
-              <a:t>Email title with [COMP2711]</a:t>
-            </a:r>
-          </a:p>
-          <a:p>
-            <a:pPr lvl="1"/>
-            <a:r>
-              <a:rPr lang="en-US" sz="3200" dirty="0">
-                <a:latin typeface="Calibri" panose="020F0502020204030204" pitchFamily="34" charset="0"/>
-                <a:cs typeface="Calibri" panose="020F0502020204030204" pitchFamily="34" charset="0"/>
-              </a:rPr>
-              <a:t>Example: “[COMP2711] Can’t do the midterm – Health Conditions”</a:t>
-            </a:r>
-          </a:p>
-        </p:txBody>
-      </p:sp>
-      <p:sp>
-        <p:nvSpPr>
-          <p:cNvPr id="4" name="Slide Number Placeholder 3">
-            <a:extLst>
-              <a:ext uri="{FF2B5EF4-FFF2-40B4-BE49-F238E27FC236}">
-                <a16:creationId xmlns:a16="http://schemas.microsoft.com/office/drawing/2014/main" id="{8BBF07DB-2A60-23DA-F180-C87EB575A815}"/>
-              </a:ext>
-            </a:extLst>
-          </p:cNvPr>
-          <p:cNvSpPr>
-            <a:spLocks noGrp="1"/>
-          </p:cNvSpPr>
-          <p:nvPr>
-            <p:ph type="sldNum" sz="quarter" idx="12"/>
-          </p:nvPr>
-        </p:nvSpPr>
-        <p:spPr/>
-        <p:txBody>
-          <a:bodyPr/>
-          <a:lstStyle/>
-          <a:p>
-            <a:fld id="{8B4C9E33-6753-472F-9C09-83153B974C9D}" type="slidenum">
-              <a:rPr lang="zh-CN" altLang="en-US" smtClean="0"/>
-              <a:t>17</a:t>
-            </a:fld>
-            <a:endParaRPr lang="zh-CN" altLang="en-US"/>
-          </a:p>
-        </p:txBody>
-      </p:sp>
-    </p:spTree>
-    <p:extLst>
-      <p:ext uri="{BB962C8B-B14F-4D97-AF65-F5344CB8AC3E}">
-        <p14:creationId xmlns:p14="http://schemas.microsoft.com/office/powerpoint/2010/main" val="2736828962"/>
       </p:ext>
     </p:extLst>
   </p:cSld>
@@ -7294,6 +7269,206 @@
           <p:cNvPr id="2" name="Title 1">
             <a:extLst>
               <a:ext uri="{FF2B5EF4-FFF2-40B4-BE49-F238E27FC236}">
+                <a16:creationId xmlns:a16="http://schemas.microsoft.com/office/drawing/2014/main" id="{0C66574F-C5FA-24F5-C088-18CF635CF786}"/>
+              </a:ext>
+            </a:extLst>
+          </p:cNvPr>
+          <p:cNvSpPr>
+            <a:spLocks noGrp="1"/>
+          </p:cNvSpPr>
+          <p:nvPr>
+            <p:ph type="title"/>
+          </p:nvPr>
+        </p:nvSpPr>
+        <p:spPr/>
+        <p:txBody>
+          <a:bodyPr/>
+          <a:lstStyle/>
+          <a:p>
+            <a:r>
+              <a:rPr lang="en-US" b="1" dirty="0">
+                <a:latin typeface="Calibri" panose="020F0502020204030204" pitchFamily="34" charset="0"/>
+                <a:cs typeface="Calibri" panose="020F0502020204030204" pitchFamily="34" charset="0"/>
+              </a:rPr>
+              <a:t>Communication</a:t>
+            </a:r>
+            <a:endParaRPr lang="en-US" dirty="0"/>
+          </a:p>
+        </p:txBody>
+      </p:sp>
+      <p:sp>
+        <p:nvSpPr>
+          <p:cNvPr id="3" name="Content Placeholder 2">
+            <a:extLst>
+              <a:ext uri="{FF2B5EF4-FFF2-40B4-BE49-F238E27FC236}">
+                <a16:creationId xmlns:a16="http://schemas.microsoft.com/office/drawing/2014/main" id="{56935A31-7449-1ADD-AECB-730CD85BAC86}"/>
+              </a:ext>
+            </a:extLst>
+          </p:cNvPr>
+          <p:cNvSpPr>
+            <a:spLocks noGrp="1"/>
+          </p:cNvSpPr>
+          <p:nvPr>
+            <p:ph idx="1"/>
+          </p:nvPr>
+        </p:nvSpPr>
+        <p:spPr/>
+        <p:txBody>
+          <a:bodyPr>
+            <a:normAutofit fontScale="92500" lnSpcReduction="20000"/>
+          </a:bodyPr>
+          <a:lstStyle/>
+          <a:p>
+            <a:r>
+              <a:rPr lang="en-US" sz="3600" b="1" dirty="0">
+                <a:latin typeface="Calibri" panose="020F0502020204030204" pitchFamily="34" charset="0"/>
+                <a:cs typeface="Calibri" panose="020F0502020204030204" pitchFamily="34" charset="0"/>
+              </a:rPr>
+              <a:t>Daily</a:t>
+            </a:r>
+          </a:p>
+          <a:p>
+            <a:pPr lvl="1"/>
+            <a:r>
+              <a:rPr lang="en-US" sz="3200" dirty="0">
+                <a:latin typeface="Calibri" panose="020F0502020204030204" pitchFamily="34" charset="0"/>
+                <a:cs typeface="Calibri" panose="020F0502020204030204" pitchFamily="34" charset="0"/>
+              </a:rPr>
+              <a:t>Q&amp;A sessions</a:t>
+            </a:r>
+          </a:p>
+          <a:p>
+            <a:pPr lvl="1"/>
+            <a:r>
+              <a:rPr lang="en-US" sz="3200" dirty="0">
+                <a:latin typeface="Calibri" panose="020F0502020204030204" pitchFamily="34" charset="0"/>
+                <a:cs typeface="Calibri" panose="020F0502020204030204" pitchFamily="34" charset="0"/>
+              </a:rPr>
+              <a:t>Canvas - Announcement</a:t>
+            </a:r>
+          </a:p>
+          <a:p>
+            <a:pPr lvl="1"/>
+            <a:r>
+              <a:rPr lang="en-US" sz="3200" dirty="0">
+                <a:latin typeface="Calibri" panose="020F0502020204030204" pitchFamily="34" charset="0"/>
+                <a:cs typeface="Calibri" panose="020F0502020204030204" pitchFamily="34" charset="0"/>
+              </a:rPr>
+              <a:t>Canvas – Discussion</a:t>
+            </a:r>
+          </a:p>
+          <a:p>
+            <a:pPr lvl="1"/>
+            <a:r>
+              <a:rPr lang="en-US" sz="3200" dirty="0">
+                <a:latin typeface="Calibri" panose="020F0502020204030204" pitchFamily="34" charset="0"/>
+                <a:cs typeface="Calibri" panose="020F0502020204030204" pitchFamily="34" charset="0"/>
+              </a:rPr>
+              <a:t>Telegram group (links on canvas)</a:t>
+            </a:r>
+          </a:p>
+          <a:p>
+            <a:pPr lvl="1"/>
+            <a:endParaRPr lang="en-US" sz="3200" dirty="0">
+              <a:latin typeface="Calibri" panose="020F0502020204030204" pitchFamily="34" charset="0"/>
+              <a:cs typeface="Calibri" panose="020F0502020204030204" pitchFamily="34" charset="0"/>
+            </a:endParaRPr>
+          </a:p>
+          <a:p>
+            <a:r>
+              <a:rPr lang="en-US" sz="3600" b="1" dirty="0">
+                <a:latin typeface="Calibri" panose="020F0502020204030204" pitchFamily="34" charset="0"/>
+                <a:cs typeface="Calibri" panose="020F0502020204030204" pitchFamily="34" charset="0"/>
+              </a:rPr>
+              <a:t>Urgent</a:t>
+            </a:r>
+          </a:p>
+          <a:p>
+            <a:pPr lvl="1"/>
+            <a:r>
+              <a:rPr lang="en-US" sz="3200" dirty="0">
+                <a:latin typeface="Calibri" panose="020F0502020204030204" pitchFamily="34" charset="0"/>
+                <a:cs typeface="Calibri" panose="020F0502020204030204" pitchFamily="34" charset="0"/>
+              </a:rPr>
+              <a:t>Email title with [COMP2711]</a:t>
+            </a:r>
+          </a:p>
+          <a:p>
+            <a:pPr lvl="1"/>
+            <a:r>
+              <a:rPr lang="en-US" sz="3200" dirty="0">
+                <a:latin typeface="Calibri" panose="020F0502020204030204" pitchFamily="34" charset="0"/>
+                <a:cs typeface="Calibri" panose="020F0502020204030204" pitchFamily="34" charset="0"/>
+              </a:rPr>
+              <a:t>Example: “[COMP2711] Can’t do the midterm – Health Conditions”</a:t>
+            </a:r>
+          </a:p>
+        </p:txBody>
+      </p:sp>
+      <p:sp>
+        <p:nvSpPr>
+          <p:cNvPr id="4" name="Slide Number Placeholder 3">
+            <a:extLst>
+              <a:ext uri="{FF2B5EF4-FFF2-40B4-BE49-F238E27FC236}">
+                <a16:creationId xmlns:a16="http://schemas.microsoft.com/office/drawing/2014/main" id="{8BBF07DB-2A60-23DA-F180-C87EB575A815}"/>
+              </a:ext>
+            </a:extLst>
+          </p:cNvPr>
+          <p:cNvSpPr>
+            <a:spLocks noGrp="1"/>
+          </p:cNvSpPr>
+          <p:nvPr>
+            <p:ph type="sldNum" sz="quarter" idx="12"/>
+          </p:nvPr>
+        </p:nvSpPr>
+        <p:spPr/>
+        <p:txBody>
+          <a:bodyPr/>
+          <a:lstStyle/>
+          <a:p>
+            <a:fld id="{8B4C9E33-6753-472F-9C09-83153B974C9D}" type="slidenum">
+              <a:rPr lang="zh-CN" altLang="en-US" smtClean="0"/>
+              <a:t>18</a:t>
+            </a:fld>
+            <a:endParaRPr lang="zh-CN" altLang="en-US"/>
+          </a:p>
+        </p:txBody>
+      </p:sp>
+    </p:spTree>
+    <p:extLst>
+      <p:ext uri="{BB962C8B-B14F-4D97-AF65-F5344CB8AC3E}">
+        <p14:creationId xmlns:p14="http://schemas.microsoft.com/office/powerpoint/2010/main" val="2736828962"/>
+      </p:ext>
+    </p:extLst>
+  </p:cSld>
+  <p:clrMapOvr>
+    <a:masterClrMapping/>
+  </p:clrMapOvr>
+</p:sld>
+</file>
+
+<file path=ppt/slides/slide19.xml><?xml version="1.0" encoding="utf-8"?>
+<p:sld xmlns:a="http://schemas.openxmlformats.org/drawingml/2006/main" xmlns:r="http://schemas.openxmlformats.org/officeDocument/2006/relationships" xmlns:p="http://schemas.openxmlformats.org/presentationml/2006/main">
+  <p:cSld>
+    <p:spTree>
+      <p:nvGrpSpPr>
+        <p:cNvPr id="1" name=""/>
+        <p:cNvGrpSpPr/>
+        <p:nvPr/>
+      </p:nvGrpSpPr>
+      <p:grpSpPr>
+        <a:xfrm>
+          <a:off x="0" y="0"/>
+          <a:ext cx="0" cy="0"/>
+          <a:chOff x="0" y="0"/>
+          <a:chExt cx="0" cy="0"/>
+        </a:xfrm>
+      </p:grpSpPr>
+      <p:sp>
+        <p:nvSpPr>
+          <p:cNvPr id="2" name="Title 1">
+            <a:extLst>
+              <a:ext uri="{FF2B5EF4-FFF2-40B4-BE49-F238E27FC236}">
                 <a16:creationId xmlns:a16="http://schemas.microsoft.com/office/drawing/2014/main" id="{AF0EC653-0D60-CA0C-BA27-ACEDD9D2A98C}"/>
               </a:ext>
             </a:extLst>
@@ -7521,7 +7696,7 @@
           <a:p>
             <a:fld id="{8B4C9E33-6753-472F-9C09-83153B974C9D}" type="slidenum">
               <a:rPr lang="zh-CN" altLang="en-US" smtClean="0"/>
-              <a:t>18</a:t>
+              <a:t>19</a:t>
             </a:fld>
             <a:endParaRPr lang="zh-CN" altLang="en-US"/>
           </a:p>
@@ -7743,7 +7918,241 @@
 </p:sld>
 </file>
 
-<file path=ppt/slides/slide19.xml><?xml version="1.0" encoding="utf-8"?>
+<file path=ppt/slides/slide2.xml><?xml version="1.0" encoding="utf-8"?>
+<p:sld xmlns:a="http://schemas.openxmlformats.org/drawingml/2006/main" xmlns:r="http://schemas.openxmlformats.org/officeDocument/2006/relationships" xmlns:p="http://schemas.openxmlformats.org/presentationml/2006/main">
+  <p:cSld>
+    <p:spTree>
+      <p:nvGrpSpPr>
+        <p:cNvPr id="1" name=""/>
+        <p:cNvGrpSpPr/>
+        <p:nvPr/>
+      </p:nvGrpSpPr>
+      <p:grpSpPr>
+        <a:xfrm>
+          <a:off x="0" y="0"/>
+          <a:ext cx="0" cy="0"/>
+          <a:chOff x="0" y="0"/>
+          <a:chExt cx="0" cy="0"/>
+        </a:xfrm>
+      </p:grpSpPr>
+      <p:sp>
+        <p:nvSpPr>
+          <p:cNvPr id="2" name="Title 1">
+            <a:extLst>
+              <a:ext uri="{FF2B5EF4-FFF2-40B4-BE49-F238E27FC236}">
+                <a16:creationId xmlns:a16="http://schemas.microsoft.com/office/drawing/2014/main" id="{AF142300-D7F7-8F3B-87C2-2633E1048258}"/>
+              </a:ext>
+            </a:extLst>
+          </p:cNvPr>
+          <p:cNvSpPr>
+            <a:spLocks noGrp="1"/>
+          </p:cNvSpPr>
+          <p:nvPr>
+            <p:ph type="title"/>
+          </p:nvPr>
+        </p:nvSpPr>
+        <p:spPr/>
+        <p:txBody>
+          <a:bodyPr/>
+          <a:lstStyle/>
+          <a:p>
+            <a:r>
+              <a:rPr lang="en-US" b="1" dirty="0">
+                <a:latin typeface="Calibri" panose="020F0502020204030204" pitchFamily="34" charset="0"/>
+                <a:cs typeface="Calibri" panose="020F0502020204030204" pitchFamily="34" charset="0"/>
+              </a:rPr>
+              <a:t>About me</a:t>
+            </a:r>
+          </a:p>
+        </p:txBody>
+      </p:sp>
+      <p:sp>
+        <p:nvSpPr>
+          <p:cNvPr id="3" name="Content Placeholder 2">
+            <a:extLst>
+              <a:ext uri="{FF2B5EF4-FFF2-40B4-BE49-F238E27FC236}">
+                <a16:creationId xmlns:a16="http://schemas.microsoft.com/office/drawing/2014/main" id="{DFFA6C19-D556-8F8A-7DAF-B1A8F4D5E7F0}"/>
+              </a:ext>
+            </a:extLst>
+          </p:cNvPr>
+          <p:cNvSpPr>
+            <a:spLocks noGrp="1"/>
+          </p:cNvSpPr>
+          <p:nvPr>
+            <p:ph idx="1"/>
+          </p:nvPr>
+        </p:nvSpPr>
+        <p:spPr/>
+        <p:txBody>
+          <a:bodyPr>
+            <a:normAutofit/>
+          </a:bodyPr>
+          <a:lstStyle/>
+          <a:p>
+            <a:r>
+              <a:rPr lang="en-US" dirty="0">
+                <a:latin typeface="Calibri" panose="020F0502020204030204" pitchFamily="34" charset="0"/>
+                <a:cs typeface="Calibri" panose="020F0502020204030204" pitchFamily="34" charset="0"/>
+              </a:rPr>
+              <a:t>Assistant Professor in HKUST CSE (since 2026)</a:t>
+            </a:r>
+          </a:p>
+          <a:p>
+            <a:r>
+              <a:rPr lang="en-US" dirty="0">
+                <a:latin typeface="Calibri" panose="020F0502020204030204" pitchFamily="34" charset="0"/>
+                <a:cs typeface="Calibri" panose="020F0502020204030204" pitchFamily="34" charset="0"/>
+              </a:rPr>
+              <a:t>PhD at Carnegie Mellon University (2025) </a:t>
+            </a:r>
+          </a:p>
+          <a:p>
+            <a:r>
+              <a:rPr lang="en-US" dirty="0">
+                <a:latin typeface="Calibri" panose="020F0502020204030204" pitchFamily="34" charset="0"/>
+                <a:cs typeface="Calibri" panose="020F0502020204030204" pitchFamily="34" charset="0"/>
+              </a:rPr>
+              <a:t>Undergrad at Peking University (2020) </a:t>
+            </a:r>
+            <a:endParaRPr lang="en-US" i="1" dirty="0">
+              <a:latin typeface="Calibri" panose="020F0502020204030204" pitchFamily="34" charset="0"/>
+              <a:cs typeface="Calibri" panose="020F0502020204030204" pitchFamily="34" charset="0"/>
+            </a:endParaRPr>
+          </a:p>
+          <a:p>
+            <a:pPr marL="0" indent="0">
+              <a:buNone/>
+            </a:pPr>
+            <a:endParaRPr lang="en-US" dirty="0">
+              <a:latin typeface="Calibri" panose="020F0502020204030204" pitchFamily="34" charset="0"/>
+              <a:cs typeface="Calibri" panose="020F0502020204030204" pitchFamily="34" charset="0"/>
+            </a:endParaRPr>
+          </a:p>
+          <a:p>
+            <a:pPr marL="0" indent="0">
+              <a:buNone/>
+            </a:pPr>
+            <a:endParaRPr lang="en-US" dirty="0">
+              <a:latin typeface="Calibri" panose="020F0502020204030204" pitchFamily="34" charset="0"/>
+              <a:cs typeface="Calibri" panose="020F0502020204030204" pitchFamily="34" charset="0"/>
+            </a:endParaRPr>
+          </a:p>
+          <a:p>
+            <a:r>
+              <a:rPr lang="en-US" dirty="0">
+                <a:latin typeface="Calibri" panose="020F0502020204030204" pitchFamily="34" charset="0"/>
+                <a:cs typeface="Calibri" panose="020F0502020204030204" pitchFamily="34" charset="0"/>
+              </a:rPr>
+              <a:t>ICPC / NOI Gold Medalist (</a:t>
+            </a:r>
+            <a:r>
+              <a:rPr lang="en-US" b="1" dirty="0">
+                <a:latin typeface="Calibri" panose="020F0502020204030204" pitchFamily="34" charset="0"/>
+                <a:cs typeface="Calibri" panose="020F0502020204030204" pitchFamily="34" charset="0"/>
+              </a:rPr>
+              <a:t>Currently: Coach of HKUST ICPC team</a:t>
+            </a:r>
+            <a:r>
+              <a:rPr lang="en-US" dirty="0">
+                <a:latin typeface="Calibri" panose="020F0502020204030204" pitchFamily="34" charset="0"/>
+                <a:cs typeface="Calibri" panose="020F0502020204030204" pitchFamily="34" charset="0"/>
+              </a:rPr>
+              <a:t>)</a:t>
+            </a:r>
+          </a:p>
+          <a:p>
+            <a:endParaRPr lang="en-US" dirty="0">
+              <a:latin typeface="Calibri" panose="020F0502020204030204" pitchFamily="34" charset="0"/>
+              <a:cs typeface="Calibri" panose="020F0502020204030204" pitchFamily="34" charset="0"/>
+            </a:endParaRPr>
+          </a:p>
+        </p:txBody>
+      </p:sp>
+      <p:sp>
+        <p:nvSpPr>
+          <p:cNvPr id="4" name="Slide Number Placeholder 3">
+            <a:extLst>
+              <a:ext uri="{FF2B5EF4-FFF2-40B4-BE49-F238E27FC236}">
+                <a16:creationId xmlns:a16="http://schemas.microsoft.com/office/drawing/2014/main" id="{FEDB2CC2-D64A-6C98-F03A-F215A208087D}"/>
+              </a:ext>
+            </a:extLst>
+          </p:cNvPr>
+          <p:cNvSpPr>
+            <a:spLocks noGrp="1"/>
+          </p:cNvSpPr>
+          <p:nvPr>
+            <p:ph type="sldNum" sz="quarter" idx="12"/>
+          </p:nvPr>
+        </p:nvSpPr>
+        <p:spPr/>
+        <p:txBody>
+          <a:bodyPr/>
+          <a:lstStyle/>
+          <a:p>
+            <a:fld id="{8B4C9E33-6753-472F-9C09-83153B974C9D}" type="slidenum">
+              <a:rPr lang="zh-CN" altLang="en-US" smtClean="0">
+                <a:latin typeface="Calibri" panose="020F0502020204030204" pitchFamily="34" charset="0"/>
+                <a:cs typeface="Calibri" panose="020F0502020204030204" pitchFamily="34" charset="0"/>
+              </a:rPr>
+              <a:t>2</a:t>
+            </a:fld>
+            <a:endParaRPr lang="zh-CN" altLang="en-US">
+              <a:latin typeface="Calibri" panose="020F0502020204030204" pitchFamily="34" charset="0"/>
+              <a:cs typeface="Calibri" panose="020F0502020204030204" pitchFamily="34" charset="0"/>
+            </a:endParaRPr>
+          </a:p>
+        </p:txBody>
+      </p:sp>
+      <p:pic>
+        <p:nvPicPr>
+          <p:cNvPr id="6" name="Picture 5">
+            <a:extLst>
+              <a:ext uri="{FF2B5EF4-FFF2-40B4-BE49-F238E27FC236}">
+                <a16:creationId xmlns:a16="http://schemas.microsoft.com/office/drawing/2014/main" id="{CF47AA7F-C925-6993-F523-0995078ECF34}"/>
+              </a:ext>
+            </a:extLst>
+          </p:cNvPr>
+          <p:cNvPicPr>
+            <a:picLocks noChangeAspect="1"/>
+          </p:cNvPicPr>
+          <p:nvPr/>
+        </p:nvPicPr>
+        <p:blipFill>
+          <a:blip r:embed="rId3">
+            <a:extLst>
+              <a:ext uri="{28A0092B-C50C-407E-A947-70E740481C1C}">
+                <a14:useLocalDpi xmlns:a14="http://schemas.microsoft.com/office/drawing/2010/main" val="0"/>
+              </a:ext>
+            </a:extLst>
+          </a:blip>
+          <a:stretch>
+            <a:fillRect/>
+          </a:stretch>
+        </p:blipFill>
+        <p:spPr>
+          <a:xfrm>
+            <a:off x="8136294" y="591878"/>
+            <a:ext cx="2833489" cy="3025077"/>
+          </a:xfrm>
+          <a:prstGeom prst="rect">
+            <a:avLst/>
+          </a:prstGeom>
+        </p:spPr>
+      </p:pic>
+    </p:spTree>
+    <p:extLst>
+      <p:ext uri="{BB962C8B-B14F-4D97-AF65-F5344CB8AC3E}">
+        <p14:creationId xmlns:p14="http://schemas.microsoft.com/office/powerpoint/2010/main" val="3308631290"/>
+      </p:ext>
+    </p:extLst>
+  </p:cSld>
+  <p:clrMapOvr>
+    <a:masterClrMapping/>
+  </p:clrMapOvr>
+</p:sld>
+</file>
+
+<file path=ppt/slides/slide20.xml><?xml version="1.0" encoding="utf-8"?>
 <p:sld xmlns:a="http://schemas.openxmlformats.org/drawingml/2006/main" xmlns:r="http://schemas.openxmlformats.org/officeDocument/2006/relationships" xmlns:p="http://schemas.openxmlformats.org/presentationml/2006/main">
   <p:cSld>
     <p:spTree>
@@ -7932,7 +8341,7 @@
           <a:p>
             <a:fld id="{8B4C9E33-6753-472F-9C09-83153B974C9D}" type="slidenum">
               <a:rPr lang="zh-CN" altLang="en-US" smtClean="0"/>
-              <a:t>19</a:t>
+              <a:t>20</a:t>
             </a:fld>
             <a:endParaRPr lang="zh-CN" altLang="en-US"/>
           </a:p>
@@ -8092,241 +8501,7 @@
 </p:sld>
 </file>
 
-<file path=ppt/slides/slide2.xml><?xml version="1.0" encoding="utf-8"?>
-<p:sld xmlns:a="http://schemas.openxmlformats.org/drawingml/2006/main" xmlns:r="http://schemas.openxmlformats.org/officeDocument/2006/relationships" xmlns:p="http://schemas.openxmlformats.org/presentationml/2006/main">
-  <p:cSld>
-    <p:spTree>
-      <p:nvGrpSpPr>
-        <p:cNvPr id="1" name=""/>
-        <p:cNvGrpSpPr/>
-        <p:nvPr/>
-      </p:nvGrpSpPr>
-      <p:grpSpPr>
-        <a:xfrm>
-          <a:off x="0" y="0"/>
-          <a:ext cx="0" cy="0"/>
-          <a:chOff x="0" y="0"/>
-          <a:chExt cx="0" cy="0"/>
-        </a:xfrm>
-      </p:grpSpPr>
-      <p:sp>
-        <p:nvSpPr>
-          <p:cNvPr id="2" name="Title 1">
-            <a:extLst>
-              <a:ext uri="{FF2B5EF4-FFF2-40B4-BE49-F238E27FC236}">
-                <a16:creationId xmlns:a16="http://schemas.microsoft.com/office/drawing/2014/main" id="{AF142300-D7F7-8F3B-87C2-2633E1048258}"/>
-              </a:ext>
-            </a:extLst>
-          </p:cNvPr>
-          <p:cNvSpPr>
-            <a:spLocks noGrp="1"/>
-          </p:cNvSpPr>
-          <p:nvPr>
-            <p:ph type="title"/>
-          </p:nvPr>
-        </p:nvSpPr>
-        <p:spPr/>
-        <p:txBody>
-          <a:bodyPr/>
-          <a:lstStyle/>
-          <a:p>
-            <a:r>
-              <a:rPr lang="en-US" b="1" dirty="0">
-                <a:latin typeface="Calibri" panose="020F0502020204030204" pitchFamily="34" charset="0"/>
-                <a:cs typeface="Calibri" panose="020F0502020204030204" pitchFamily="34" charset="0"/>
-              </a:rPr>
-              <a:t>About me</a:t>
-            </a:r>
-          </a:p>
-        </p:txBody>
-      </p:sp>
-      <p:sp>
-        <p:nvSpPr>
-          <p:cNvPr id="3" name="Content Placeholder 2">
-            <a:extLst>
-              <a:ext uri="{FF2B5EF4-FFF2-40B4-BE49-F238E27FC236}">
-                <a16:creationId xmlns:a16="http://schemas.microsoft.com/office/drawing/2014/main" id="{DFFA6C19-D556-8F8A-7DAF-B1A8F4D5E7F0}"/>
-              </a:ext>
-            </a:extLst>
-          </p:cNvPr>
-          <p:cNvSpPr>
-            <a:spLocks noGrp="1"/>
-          </p:cNvSpPr>
-          <p:nvPr>
-            <p:ph idx="1"/>
-          </p:nvPr>
-        </p:nvSpPr>
-        <p:spPr/>
-        <p:txBody>
-          <a:bodyPr>
-            <a:normAutofit/>
-          </a:bodyPr>
-          <a:lstStyle/>
-          <a:p>
-            <a:r>
-              <a:rPr lang="en-US" dirty="0">
-                <a:latin typeface="Calibri" panose="020F0502020204030204" pitchFamily="34" charset="0"/>
-                <a:cs typeface="Calibri" panose="020F0502020204030204" pitchFamily="34" charset="0"/>
-              </a:rPr>
-              <a:t>Assistant Professor in HKUST CSE (since 2026)</a:t>
-            </a:r>
-          </a:p>
-          <a:p>
-            <a:r>
-              <a:rPr lang="en-US" dirty="0">
-                <a:latin typeface="Calibri" panose="020F0502020204030204" pitchFamily="34" charset="0"/>
-                <a:cs typeface="Calibri" panose="020F0502020204030204" pitchFamily="34" charset="0"/>
-              </a:rPr>
-              <a:t>PhD at Carnegie Mellon University (2025) </a:t>
-            </a:r>
-          </a:p>
-          <a:p>
-            <a:r>
-              <a:rPr lang="en-US" dirty="0">
-                <a:latin typeface="Calibri" panose="020F0502020204030204" pitchFamily="34" charset="0"/>
-                <a:cs typeface="Calibri" panose="020F0502020204030204" pitchFamily="34" charset="0"/>
-              </a:rPr>
-              <a:t>Undergrad at Peking University (2020) </a:t>
-            </a:r>
-            <a:endParaRPr lang="en-US" i="1" dirty="0">
-              <a:latin typeface="Calibri" panose="020F0502020204030204" pitchFamily="34" charset="0"/>
-              <a:cs typeface="Calibri" panose="020F0502020204030204" pitchFamily="34" charset="0"/>
-            </a:endParaRPr>
-          </a:p>
-          <a:p>
-            <a:pPr marL="0" indent="0">
-              <a:buNone/>
-            </a:pPr>
-            <a:endParaRPr lang="en-US" dirty="0">
-              <a:latin typeface="Calibri" panose="020F0502020204030204" pitchFamily="34" charset="0"/>
-              <a:cs typeface="Calibri" panose="020F0502020204030204" pitchFamily="34" charset="0"/>
-            </a:endParaRPr>
-          </a:p>
-          <a:p>
-            <a:pPr marL="0" indent="0">
-              <a:buNone/>
-            </a:pPr>
-            <a:endParaRPr lang="en-US" dirty="0">
-              <a:latin typeface="Calibri" panose="020F0502020204030204" pitchFamily="34" charset="0"/>
-              <a:cs typeface="Calibri" panose="020F0502020204030204" pitchFamily="34" charset="0"/>
-            </a:endParaRPr>
-          </a:p>
-          <a:p>
-            <a:r>
-              <a:rPr lang="en-US" dirty="0">
-                <a:latin typeface="Calibri" panose="020F0502020204030204" pitchFamily="34" charset="0"/>
-                <a:cs typeface="Calibri" panose="020F0502020204030204" pitchFamily="34" charset="0"/>
-              </a:rPr>
-              <a:t>ICPC / NOI Gold Medalist (</a:t>
-            </a:r>
-            <a:r>
-              <a:rPr lang="en-US" b="1" dirty="0">
-                <a:latin typeface="Calibri" panose="020F0502020204030204" pitchFamily="34" charset="0"/>
-                <a:cs typeface="Calibri" panose="020F0502020204030204" pitchFamily="34" charset="0"/>
-              </a:rPr>
-              <a:t>Currently: Coach of HKUST ICPC team</a:t>
-            </a:r>
-            <a:r>
-              <a:rPr lang="en-US" dirty="0">
-                <a:latin typeface="Calibri" panose="020F0502020204030204" pitchFamily="34" charset="0"/>
-                <a:cs typeface="Calibri" panose="020F0502020204030204" pitchFamily="34" charset="0"/>
-              </a:rPr>
-              <a:t>)</a:t>
-            </a:r>
-          </a:p>
-          <a:p>
-            <a:endParaRPr lang="en-US" dirty="0">
-              <a:latin typeface="Calibri" panose="020F0502020204030204" pitchFamily="34" charset="0"/>
-              <a:cs typeface="Calibri" panose="020F0502020204030204" pitchFamily="34" charset="0"/>
-            </a:endParaRPr>
-          </a:p>
-        </p:txBody>
-      </p:sp>
-      <p:sp>
-        <p:nvSpPr>
-          <p:cNvPr id="4" name="Slide Number Placeholder 3">
-            <a:extLst>
-              <a:ext uri="{FF2B5EF4-FFF2-40B4-BE49-F238E27FC236}">
-                <a16:creationId xmlns:a16="http://schemas.microsoft.com/office/drawing/2014/main" id="{FEDB2CC2-D64A-6C98-F03A-F215A208087D}"/>
-              </a:ext>
-            </a:extLst>
-          </p:cNvPr>
-          <p:cNvSpPr>
-            <a:spLocks noGrp="1"/>
-          </p:cNvSpPr>
-          <p:nvPr>
-            <p:ph type="sldNum" sz="quarter" idx="12"/>
-          </p:nvPr>
-        </p:nvSpPr>
-        <p:spPr/>
-        <p:txBody>
-          <a:bodyPr/>
-          <a:lstStyle/>
-          <a:p>
-            <a:fld id="{8B4C9E33-6753-472F-9C09-83153B974C9D}" type="slidenum">
-              <a:rPr lang="zh-CN" altLang="en-US" smtClean="0">
-                <a:latin typeface="Calibri" panose="020F0502020204030204" pitchFamily="34" charset="0"/>
-                <a:cs typeface="Calibri" panose="020F0502020204030204" pitchFamily="34" charset="0"/>
-              </a:rPr>
-              <a:t>2</a:t>
-            </a:fld>
-            <a:endParaRPr lang="zh-CN" altLang="en-US">
-              <a:latin typeface="Calibri" panose="020F0502020204030204" pitchFamily="34" charset="0"/>
-              <a:cs typeface="Calibri" panose="020F0502020204030204" pitchFamily="34" charset="0"/>
-            </a:endParaRPr>
-          </a:p>
-        </p:txBody>
-      </p:sp>
-      <p:pic>
-        <p:nvPicPr>
-          <p:cNvPr id="6" name="Picture 5">
-            <a:extLst>
-              <a:ext uri="{FF2B5EF4-FFF2-40B4-BE49-F238E27FC236}">
-                <a16:creationId xmlns:a16="http://schemas.microsoft.com/office/drawing/2014/main" id="{CF47AA7F-C925-6993-F523-0995078ECF34}"/>
-              </a:ext>
-            </a:extLst>
-          </p:cNvPr>
-          <p:cNvPicPr>
-            <a:picLocks noChangeAspect="1"/>
-          </p:cNvPicPr>
-          <p:nvPr/>
-        </p:nvPicPr>
-        <p:blipFill>
-          <a:blip r:embed="rId3">
-            <a:extLst>
-              <a:ext uri="{28A0092B-C50C-407E-A947-70E740481C1C}">
-                <a14:useLocalDpi xmlns:a14="http://schemas.microsoft.com/office/drawing/2010/main" val="0"/>
-              </a:ext>
-            </a:extLst>
-          </a:blip>
-          <a:stretch>
-            <a:fillRect/>
-          </a:stretch>
-        </p:blipFill>
-        <p:spPr>
-          <a:xfrm>
-            <a:off x="8136294" y="591878"/>
-            <a:ext cx="2833489" cy="3025077"/>
-          </a:xfrm>
-          <a:prstGeom prst="rect">
-            <a:avLst/>
-          </a:prstGeom>
-        </p:spPr>
-      </p:pic>
-    </p:spTree>
-    <p:extLst>
-      <p:ext uri="{BB962C8B-B14F-4D97-AF65-F5344CB8AC3E}">
-        <p14:creationId xmlns:p14="http://schemas.microsoft.com/office/powerpoint/2010/main" val="3308631290"/>
-      </p:ext>
-    </p:extLst>
-  </p:cSld>
-  <p:clrMapOvr>
-    <a:masterClrMapping/>
-  </p:clrMapOvr>
-</p:sld>
-</file>
-
-<file path=ppt/slides/slide20.xml><?xml version="1.0" encoding="utf-8"?>
+<file path=ppt/slides/slide21.xml><?xml version="1.0" encoding="utf-8"?>
 <p:sld xmlns:a="http://schemas.openxmlformats.org/drawingml/2006/main" xmlns:r="http://schemas.openxmlformats.org/officeDocument/2006/relationships" xmlns:p="http://schemas.openxmlformats.org/presentationml/2006/main">
   <p:cSld>
     <p:spTree>
@@ -8500,7 +8675,7 @@
           <a:p>
             <a:fld id="{8B4C9E33-6753-472F-9C09-83153B974C9D}" type="slidenum">
               <a:rPr lang="zh-CN" altLang="en-US" smtClean="0"/>
-              <a:t>20</a:t>
+              <a:t>21</a:t>
             </a:fld>
             <a:endParaRPr lang="zh-CN" altLang="en-US"/>
           </a:p>
@@ -8694,7 +8869,7 @@
 </p:sld>
 </file>
 
-<file path=ppt/slides/slide21.xml><?xml version="1.0" encoding="utf-8"?>
+<file path=ppt/slides/slide22.xml><?xml version="1.0" encoding="utf-8"?>
 <p:sld xmlns:a="http://schemas.openxmlformats.org/drawingml/2006/main" xmlns:r="http://schemas.openxmlformats.org/officeDocument/2006/relationships" xmlns:p="http://schemas.openxmlformats.org/presentationml/2006/main">
   <p:cSld>
     <p:spTree>
@@ -8950,7 +9125,7 @@
                 <a:latin typeface="Calibri" panose="020F0502020204030204" pitchFamily="34" charset="0"/>
                 <a:cs typeface="Calibri" panose="020F0502020204030204" pitchFamily="34" charset="0"/>
               </a:rPr>
-              <a:t>21</a:t>
+              <a:t>22</a:t>
             </a:fld>
             <a:endParaRPr lang="zh-CN" altLang="en-US">
               <a:latin typeface="Calibri" panose="020F0502020204030204" pitchFamily="34" charset="0"/>
@@ -8972,7 +9147,7 @@
 </p:sld>
 </file>
 
-<file path=ppt/slides/slide22.xml><?xml version="1.0" encoding="utf-8"?>
+<file path=ppt/slides/slide23.xml><?xml version="1.0" encoding="utf-8"?>
 <p:sld xmlns:a="http://schemas.openxmlformats.org/drawingml/2006/main" xmlns:r="http://schemas.openxmlformats.org/officeDocument/2006/relationships" xmlns:p="http://schemas.openxmlformats.org/presentationml/2006/main">
   <p:cSld>
     <p:spTree>
@@ -9044,7 +9219,7 @@
                 <a:latin typeface="Calibri" panose="020F0502020204030204" pitchFamily="34" charset="0"/>
                 <a:cs typeface="Calibri" panose="020F0502020204030204" pitchFamily="34" charset="0"/>
               </a:rPr>
-              <a:t>22</a:t>
+              <a:t>23</a:t>
             </a:fld>
             <a:endParaRPr lang="zh-CN" altLang="en-US">
               <a:latin typeface="Calibri" panose="020F0502020204030204" pitchFamily="34" charset="0"/>
@@ -9061,7 +9236,7 @@
 </p:sld>
 </file>
 
-<file path=ppt/slides/slide23.xml><?xml version="1.0" encoding="utf-8"?>
+<file path=ppt/slides/slide24.xml><?xml version="1.0" encoding="utf-8"?>
 <p:sld xmlns:a="http://schemas.openxmlformats.org/drawingml/2006/main" xmlns:r="http://schemas.openxmlformats.org/officeDocument/2006/relationships" xmlns:p="http://schemas.openxmlformats.org/presentationml/2006/main">
   <p:cSld>
     <p:bg>
@@ -9149,7 +9324,7 @@
 </p:sld>
 </file>
 
-<file path=ppt/slides/slide24.xml><?xml version="1.0" encoding="utf-8"?>
+<file path=ppt/slides/slide25.xml><?xml version="1.0" encoding="utf-8"?>
 <p:sld xmlns:a="http://schemas.openxmlformats.org/drawingml/2006/main" xmlns:r="http://schemas.openxmlformats.org/officeDocument/2006/relationships" xmlns:p="http://schemas.openxmlformats.org/presentationml/2006/main">
   <p:cSld>
     <p:spTree>
@@ -9220,7 +9395,7 @@
           <a:p>
             <a:fld id="{8B4C9E33-6753-472F-9C09-83153B974C9D}" type="slidenum">
               <a:rPr lang="zh-CN" altLang="en-US" smtClean="0"/>
-              <a:t>24</a:t>
+              <a:t>25</a:t>
             </a:fld>
             <a:endParaRPr lang="zh-CN" altLang="en-US" dirty="0"/>
           </a:p>
@@ -9559,7 +9734,7 @@
 </p:sld>
 </file>
 
-<file path=ppt/slides/slide25.xml><?xml version="1.0" encoding="utf-8"?>
+<file path=ppt/slides/slide26.xml><?xml version="1.0" encoding="utf-8"?>
 <p:sld xmlns:a="http://schemas.openxmlformats.org/drawingml/2006/main" xmlns:r="http://schemas.openxmlformats.org/officeDocument/2006/relationships" xmlns:p="http://schemas.openxmlformats.org/presentationml/2006/main">
   <p:cSld>
     <p:spTree>
@@ -9636,7 +9811,7 @@
           <a:p>
             <a:fld id="{8B4C9E33-6753-472F-9C09-83153B974C9D}" type="slidenum">
               <a:rPr lang="zh-CN" altLang="en-US" smtClean="0"/>
-              <a:t>25</a:t>
+              <a:t>26</a:t>
             </a:fld>
             <a:endParaRPr lang="zh-CN" altLang="en-US" dirty="0"/>
           </a:p>
@@ -9854,7 +10029,7 @@
 </p:sld>
 </file>
 
-<file path=ppt/slides/slide26.xml><?xml version="1.0" encoding="utf-8"?>
+<file path=ppt/slides/slide27.xml><?xml version="1.0" encoding="utf-8"?>
 <p:sld xmlns:a="http://schemas.openxmlformats.org/drawingml/2006/main" xmlns:r="http://schemas.openxmlformats.org/officeDocument/2006/relationships" xmlns:p="http://schemas.openxmlformats.org/presentationml/2006/main">
   <p:cSld>
     <p:spTree>
@@ -9931,7 +10106,7 @@
           <a:p>
             <a:fld id="{8B4C9E33-6753-472F-9C09-83153B974C9D}" type="slidenum">
               <a:rPr lang="zh-CN" altLang="en-US" smtClean="0"/>
-              <a:t>26</a:t>
+              <a:t>27</a:t>
             </a:fld>
             <a:endParaRPr lang="zh-CN" altLang="en-US" dirty="0"/>
           </a:p>
@@ -10204,7 +10379,7 @@
 </p:sld>
 </file>
 
-<file path=ppt/slides/slide27.xml><?xml version="1.0" encoding="utf-8"?>
+<file path=ppt/slides/slide28.xml><?xml version="1.0" encoding="utf-8"?>
 <p:sld xmlns:a="http://schemas.openxmlformats.org/drawingml/2006/main" xmlns:r="http://schemas.openxmlformats.org/officeDocument/2006/relationships" xmlns:p="http://schemas.openxmlformats.org/presentationml/2006/main">
   <p:cSld>
     <p:spTree>
@@ -10281,7 +10456,7 @@
           <a:p>
             <a:fld id="{8B4C9E33-6753-472F-9C09-83153B974C9D}" type="slidenum">
               <a:rPr lang="zh-CN" altLang="en-US" smtClean="0"/>
-              <a:t>27</a:t>
+              <a:t>28</a:t>
             </a:fld>
             <a:endParaRPr lang="zh-CN" altLang="en-US" dirty="0"/>
           </a:p>
@@ -10691,7 +10866,7 @@
 </p:sld>
 </file>
 
-<file path=ppt/slides/slide28.xml><?xml version="1.0" encoding="utf-8"?>
+<file path=ppt/slides/slide29.xml><?xml version="1.0" encoding="utf-8"?>
 <p:sld xmlns:a="http://schemas.openxmlformats.org/drawingml/2006/main" xmlns:r="http://schemas.openxmlformats.org/officeDocument/2006/relationships" xmlns:p="http://schemas.openxmlformats.org/presentationml/2006/main">
   <p:cSld>
     <p:spTree>
@@ -10807,7 +10982,7 @@
           <a:p>
             <a:fld id="{8B4C9E33-6753-472F-9C09-83153B974C9D}" type="slidenum">
               <a:rPr lang="zh-CN" altLang="en-US" smtClean="0"/>
-              <a:t>28</a:t>
+              <a:t>29</a:t>
             </a:fld>
             <a:endParaRPr lang="zh-CN" altLang="en-US"/>
           </a:p>
@@ -10883,222 +11058,6 @@
     <p:extLst>
       <p:ext uri="{BB962C8B-B14F-4D97-AF65-F5344CB8AC3E}">
         <p14:creationId xmlns:p14="http://schemas.microsoft.com/office/powerpoint/2010/main" val="4291667523"/>
-      </p:ext>
-    </p:extLst>
-  </p:cSld>
-  <p:clrMapOvr>
-    <a:masterClrMapping/>
-  </p:clrMapOvr>
-</p:sld>
-</file>
-
-<file path=ppt/slides/slide29.xml><?xml version="1.0" encoding="utf-8"?>
-<p:sld xmlns:a="http://schemas.openxmlformats.org/drawingml/2006/main" xmlns:r="http://schemas.openxmlformats.org/officeDocument/2006/relationships" xmlns:p="http://schemas.openxmlformats.org/presentationml/2006/main">
-  <p:cSld>
-    <p:spTree>
-      <p:nvGrpSpPr>
-        <p:cNvPr id="1" name="">
-          <a:extLst>
-            <a:ext uri="{FF2B5EF4-FFF2-40B4-BE49-F238E27FC236}">
-              <a16:creationId xmlns:a16="http://schemas.microsoft.com/office/drawing/2014/main" id="{A6DFE8C4-EF1D-1066-F9DF-B2E1527657FC}"/>
-            </a:ext>
-          </a:extLst>
-        </p:cNvPr>
-        <p:cNvGrpSpPr/>
-        <p:nvPr/>
-      </p:nvGrpSpPr>
-      <p:grpSpPr>
-        <a:xfrm>
-          <a:off x="0" y="0"/>
-          <a:ext cx="0" cy="0"/>
-          <a:chOff x="0" y="0"/>
-          <a:chExt cx="0" cy="0"/>
-        </a:xfrm>
-      </p:grpSpPr>
-      <p:sp>
-        <p:nvSpPr>
-          <p:cNvPr id="2" name="Title 1">
-            <a:extLst>
-              <a:ext uri="{FF2B5EF4-FFF2-40B4-BE49-F238E27FC236}">
-                <a16:creationId xmlns:a16="http://schemas.microsoft.com/office/drawing/2014/main" id="{4BC7807F-D249-B61E-024A-A2B583D63DC7}"/>
-              </a:ext>
-            </a:extLst>
-          </p:cNvPr>
-          <p:cNvSpPr>
-            <a:spLocks noGrp="1"/>
-          </p:cNvSpPr>
-          <p:nvPr>
-            <p:ph type="title"/>
-          </p:nvPr>
-        </p:nvSpPr>
-        <p:spPr/>
-        <p:txBody>
-          <a:bodyPr/>
-          <a:lstStyle/>
-          <a:p>
-            <a:r>
-              <a:rPr lang="en-US" dirty="0">
-                <a:latin typeface="Calibri" panose="020F0502020204030204" pitchFamily="34" charset="0"/>
-                <a:cs typeface="Calibri" panose="020F0502020204030204" pitchFamily="34" charset="0"/>
-              </a:rPr>
-              <a:t>Chessboard problem</a:t>
-            </a:r>
-          </a:p>
-        </p:txBody>
-      </p:sp>
-      <p:sp>
-        <p:nvSpPr>
-          <p:cNvPr id="3" name="Content Placeholder 2">
-            <a:extLst>
-              <a:ext uri="{FF2B5EF4-FFF2-40B4-BE49-F238E27FC236}">
-                <a16:creationId xmlns:a16="http://schemas.microsoft.com/office/drawing/2014/main" id="{6B9F4EAA-A4FB-0FA1-82E0-0825D26CA2BB}"/>
-              </a:ext>
-            </a:extLst>
-          </p:cNvPr>
-          <p:cNvSpPr>
-            <a:spLocks noGrp="1"/>
-          </p:cNvSpPr>
-          <p:nvPr>
-            <p:ph idx="1"/>
-          </p:nvPr>
-        </p:nvSpPr>
-        <p:spPr>
-          <a:xfrm>
-            <a:off x="838200" y="1825625"/>
-            <a:ext cx="6926705" cy="4351338"/>
-          </a:xfrm>
-        </p:spPr>
-        <p:txBody>
-          <a:bodyPr/>
-          <a:lstStyle/>
-          <a:p>
-            <a:r>
-              <a:rPr lang="en-US" dirty="0"/>
-              <a:t>No – because each domino covers exactly two opposite-color grid. </a:t>
-            </a:r>
-          </a:p>
-          <a:p>
-            <a:endParaRPr lang="en-US" dirty="0"/>
-          </a:p>
-          <a:p>
-            <a:r>
-              <a:rPr lang="en-US" dirty="0"/>
-              <a:t>The remaining 62 squares has 30 light-color grids and 32 black grids.</a:t>
-            </a:r>
-          </a:p>
-          <a:p>
-            <a:endParaRPr lang="en-US" dirty="0"/>
-          </a:p>
-          <a:p>
-            <a:r>
-              <a:rPr lang="en-US" dirty="0"/>
-              <a:t>Never balance! </a:t>
-            </a:r>
-          </a:p>
-          <a:p>
-            <a:endParaRPr lang="en-US" dirty="0"/>
-          </a:p>
-        </p:txBody>
-      </p:sp>
-      <p:sp>
-        <p:nvSpPr>
-          <p:cNvPr id="4" name="Slide Number Placeholder 3">
-            <a:extLst>
-              <a:ext uri="{FF2B5EF4-FFF2-40B4-BE49-F238E27FC236}">
-                <a16:creationId xmlns:a16="http://schemas.microsoft.com/office/drawing/2014/main" id="{3765A17D-E831-F50E-A141-03C33E5BE1BE}"/>
-              </a:ext>
-            </a:extLst>
-          </p:cNvPr>
-          <p:cNvSpPr>
-            <a:spLocks noGrp="1"/>
-          </p:cNvSpPr>
-          <p:nvPr>
-            <p:ph type="sldNum" sz="quarter" idx="12"/>
-          </p:nvPr>
-        </p:nvSpPr>
-        <p:spPr/>
-        <p:txBody>
-          <a:bodyPr/>
-          <a:lstStyle/>
-          <a:p>
-            <a:fld id="{8B4C9E33-6753-472F-9C09-83153B974C9D}" type="slidenum">
-              <a:rPr lang="zh-CN" altLang="en-US" smtClean="0"/>
-              <a:t>29</a:t>
-            </a:fld>
-            <a:endParaRPr lang="zh-CN" altLang="en-US"/>
-          </a:p>
-        </p:txBody>
-      </p:sp>
-      <p:pic>
-        <p:nvPicPr>
-          <p:cNvPr id="5" name="Picture 4">
-            <a:extLst>
-              <a:ext uri="{FF2B5EF4-FFF2-40B4-BE49-F238E27FC236}">
-                <a16:creationId xmlns:a16="http://schemas.microsoft.com/office/drawing/2014/main" id="{5757DAE6-3ADA-61EC-C780-56EC0D75334D}"/>
-              </a:ext>
-            </a:extLst>
-          </p:cNvPr>
-          <p:cNvPicPr>
-            <a:picLocks noChangeAspect="1"/>
-          </p:cNvPicPr>
-          <p:nvPr/>
-        </p:nvPicPr>
-        <p:blipFill>
-          <a:blip r:embed="rId2"/>
-          <a:stretch>
-            <a:fillRect/>
-          </a:stretch>
-        </p:blipFill>
-        <p:spPr>
-          <a:xfrm>
-            <a:off x="7625726" y="1885547"/>
-            <a:ext cx="4231494" cy="4231494"/>
-          </a:xfrm>
-          <a:prstGeom prst="rect">
-            <a:avLst/>
-          </a:prstGeom>
-        </p:spPr>
-      </p:pic>
-      <p:pic>
-        <p:nvPicPr>
-          <p:cNvPr id="7" name="Picture 6">
-            <a:extLst>
-              <a:ext uri="{FF2B5EF4-FFF2-40B4-BE49-F238E27FC236}">
-                <a16:creationId xmlns:a16="http://schemas.microsoft.com/office/drawing/2014/main" id="{87CFE2B5-6E66-5D0C-EDBF-2B55D8708B9E}"/>
-              </a:ext>
-            </a:extLst>
-          </p:cNvPr>
-          <p:cNvPicPr>
-            <a:picLocks noChangeAspect="1"/>
-          </p:cNvPicPr>
-          <p:nvPr/>
-        </p:nvPicPr>
-        <p:blipFill>
-          <a:blip r:embed="rId3">
-            <a:extLst>
-              <a:ext uri="{28A0092B-C50C-407E-A947-70E740481C1C}">
-                <a14:useLocalDpi xmlns:a14="http://schemas.microsoft.com/office/drawing/2010/main" val="0"/>
-              </a:ext>
-            </a:extLst>
-          </a:blip>
-          <a:stretch>
-            <a:fillRect/>
-          </a:stretch>
-        </p:blipFill>
-        <p:spPr>
-          <a:xfrm>
-            <a:off x="5499690" y="5071556"/>
-            <a:ext cx="1986518" cy="1229158"/>
-          </a:xfrm>
-          <a:prstGeom prst="rect">
-            <a:avLst/>
-          </a:prstGeom>
-        </p:spPr>
-      </p:pic>
-    </p:spTree>
-    <p:extLst>
-      <p:ext uri="{BB962C8B-B14F-4D97-AF65-F5344CB8AC3E}">
-        <p14:creationId xmlns:p14="http://schemas.microsoft.com/office/powerpoint/2010/main" val="1510048797"/>
       </p:ext>
     </p:extLst>
   </p:cSld>
@@ -11543,6 +11502,222 @@
         <p:cNvPr id="1" name="">
           <a:extLst>
             <a:ext uri="{FF2B5EF4-FFF2-40B4-BE49-F238E27FC236}">
+              <a16:creationId xmlns:a16="http://schemas.microsoft.com/office/drawing/2014/main" id="{A6DFE8C4-EF1D-1066-F9DF-B2E1527657FC}"/>
+            </a:ext>
+          </a:extLst>
+        </p:cNvPr>
+        <p:cNvGrpSpPr/>
+        <p:nvPr/>
+      </p:nvGrpSpPr>
+      <p:grpSpPr>
+        <a:xfrm>
+          <a:off x="0" y="0"/>
+          <a:ext cx="0" cy="0"/>
+          <a:chOff x="0" y="0"/>
+          <a:chExt cx="0" cy="0"/>
+        </a:xfrm>
+      </p:grpSpPr>
+      <p:sp>
+        <p:nvSpPr>
+          <p:cNvPr id="2" name="Title 1">
+            <a:extLst>
+              <a:ext uri="{FF2B5EF4-FFF2-40B4-BE49-F238E27FC236}">
+                <a16:creationId xmlns:a16="http://schemas.microsoft.com/office/drawing/2014/main" id="{4BC7807F-D249-B61E-024A-A2B583D63DC7}"/>
+              </a:ext>
+            </a:extLst>
+          </p:cNvPr>
+          <p:cNvSpPr>
+            <a:spLocks noGrp="1"/>
+          </p:cNvSpPr>
+          <p:nvPr>
+            <p:ph type="title"/>
+          </p:nvPr>
+        </p:nvSpPr>
+        <p:spPr/>
+        <p:txBody>
+          <a:bodyPr/>
+          <a:lstStyle/>
+          <a:p>
+            <a:r>
+              <a:rPr lang="en-US" dirty="0">
+                <a:latin typeface="Calibri" panose="020F0502020204030204" pitchFamily="34" charset="0"/>
+                <a:cs typeface="Calibri" panose="020F0502020204030204" pitchFamily="34" charset="0"/>
+              </a:rPr>
+              <a:t>Chessboard problem</a:t>
+            </a:r>
+          </a:p>
+        </p:txBody>
+      </p:sp>
+      <p:sp>
+        <p:nvSpPr>
+          <p:cNvPr id="3" name="Content Placeholder 2">
+            <a:extLst>
+              <a:ext uri="{FF2B5EF4-FFF2-40B4-BE49-F238E27FC236}">
+                <a16:creationId xmlns:a16="http://schemas.microsoft.com/office/drawing/2014/main" id="{6B9F4EAA-A4FB-0FA1-82E0-0825D26CA2BB}"/>
+              </a:ext>
+            </a:extLst>
+          </p:cNvPr>
+          <p:cNvSpPr>
+            <a:spLocks noGrp="1"/>
+          </p:cNvSpPr>
+          <p:nvPr>
+            <p:ph idx="1"/>
+          </p:nvPr>
+        </p:nvSpPr>
+        <p:spPr>
+          <a:xfrm>
+            <a:off x="838200" y="1825625"/>
+            <a:ext cx="6926705" cy="4351338"/>
+          </a:xfrm>
+        </p:spPr>
+        <p:txBody>
+          <a:bodyPr/>
+          <a:lstStyle/>
+          <a:p>
+            <a:r>
+              <a:rPr lang="en-US" dirty="0"/>
+              <a:t>No – because each domino covers exactly two opposite-color grid. </a:t>
+            </a:r>
+          </a:p>
+          <a:p>
+            <a:endParaRPr lang="en-US" dirty="0"/>
+          </a:p>
+          <a:p>
+            <a:r>
+              <a:rPr lang="en-US" dirty="0"/>
+              <a:t>The remaining 62 squares has 30 light-color grids and 32 black grids.</a:t>
+            </a:r>
+          </a:p>
+          <a:p>
+            <a:endParaRPr lang="en-US" dirty="0"/>
+          </a:p>
+          <a:p>
+            <a:r>
+              <a:rPr lang="en-US" dirty="0"/>
+              <a:t>Never balance! </a:t>
+            </a:r>
+          </a:p>
+          <a:p>
+            <a:endParaRPr lang="en-US" dirty="0"/>
+          </a:p>
+        </p:txBody>
+      </p:sp>
+      <p:sp>
+        <p:nvSpPr>
+          <p:cNvPr id="4" name="Slide Number Placeholder 3">
+            <a:extLst>
+              <a:ext uri="{FF2B5EF4-FFF2-40B4-BE49-F238E27FC236}">
+                <a16:creationId xmlns:a16="http://schemas.microsoft.com/office/drawing/2014/main" id="{3765A17D-E831-F50E-A141-03C33E5BE1BE}"/>
+              </a:ext>
+            </a:extLst>
+          </p:cNvPr>
+          <p:cNvSpPr>
+            <a:spLocks noGrp="1"/>
+          </p:cNvSpPr>
+          <p:nvPr>
+            <p:ph type="sldNum" sz="quarter" idx="12"/>
+          </p:nvPr>
+        </p:nvSpPr>
+        <p:spPr/>
+        <p:txBody>
+          <a:bodyPr/>
+          <a:lstStyle/>
+          <a:p>
+            <a:fld id="{8B4C9E33-6753-472F-9C09-83153B974C9D}" type="slidenum">
+              <a:rPr lang="zh-CN" altLang="en-US" smtClean="0"/>
+              <a:t>30</a:t>
+            </a:fld>
+            <a:endParaRPr lang="zh-CN" altLang="en-US"/>
+          </a:p>
+        </p:txBody>
+      </p:sp>
+      <p:pic>
+        <p:nvPicPr>
+          <p:cNvPr id="5" name="Picture 4">
+            <a:extLst>
+              <a:ext uri="{FF2B5EF4-FFF2-40B4-BE49-F238E27FC236}">
+                <a16:creationId xmlns:a16="http://schemas.microsoft.com/office/drawing/2014/main" id="{5757DAE6-3ADA-61EC-C780-56EC0D75334D}"/>
+              </a:ext>
+            </a:extLst>
+          </p:cNvPr>
+          <p:cNvPicPr>
+            <a:picLocks noChangeAspect="1"/>
+          </p:cNvPicPr>
+          <p:nvPr/>
+        </p:nvPicPr>
+        <p:blipFill>
+          <a:blip r:embed="rId2"/>
+          <a:stretch>
+            <a:fillRect/>
+          </a:stretch>
+        </p:blipFill>
+        <p:spPr>
+          <a:xfrm>
+            <a:off x="7625726" y="1885547"/>
+            <a:ext cx="4231494" cy="4231494"/>
+          </a:xfrm>
+          <a:prstGeom prst="rect">
+            <a:avLst/>
+          </a:prstGeom>
+        </p:spPr>
+      </p:pic>
+      <p:pic>
+        <p:nvPicPr>
+          <p:cNvPr id="7" name="Picture 6">
+            <a:extLst>
+              <a:ext uri="{FF2B5EF4-FFF2-40B4-BE49-F238E27FC236}">
+                <a16:creationId xmlns:a16="http://schemas.microsoft.com/office/drawing/2014/main" id="{87CFE2B5-6E66-5D0C-EDBF-2B55D8708B9E}"/>
+              </a:ext>
+            </a:extLst>
+          </p:cNvPr>
+          <p:cNvPicPr>
+            <a:picLocks noChangeAspect="1"/>
+          </p:cNvPicPr>
+          <p:nvPr/>
+        </p:nvPicPr>
+        <p:blipFill>
+          <a:blip r:embed="rId3">
+            <a:extLst>
+              <a:ext uri="{28A0092B-C50C-407E-A947-70E740481C1C}">
+                <a14:useLocalDpi xmlns:a14="http://schemas.microsoft.com/office/drawing/2010/main" val="0"/>
+              </a:ext>
+            </a:extLst>
+          </a:blip>
+          <a:stretch>
+            <a:fillRect/>
+          </a:stretch>
+        </p:blipFill>
+        <p:spPr>
+          <a:xfrm>
+            <a:off x="5499690" y="5071556"/>
+            <a:ext cx="1986518" cy="1229158"/>
+          </a:xfrm>
+          <a:prstGeom prst="rect">
+            <a:avLst/>
+          </a:prstGeom>
+        </p:spPr>
+      </p:pic>
+    </p:spTree>
+    <p:extLst>
+      <p:ext uri="{BB962C8B-B14F-4D97-AF65-F5344CB8AC3E}">
+        <p14:creationId xmlns:p14="http://schemas.microsoft.com/office/powerpoint/2010/main" val="1510048797"/>
+      </p:ext>
+    </p:extLst>
+  </p:cSld>
+  <p:clrMapOvr>
+    <a:masterClrMapping/>
+  </p:clrMapOvr>
+</p:sld>
+</file>
+
+<file path=ppt/slides/slide31.xml><?xml version="1.0" encoding="utf-8"?>
+<p:sld xmlns:a="http://schemas.openxmlformats.org/drawingml/2006/main" xmlns:r="http://schemas.openxmlformats.org/officeDocument/2006/relationships" xmlns:p="http://schemas.openxmlformats.org/presentationml/2006/main">
+  <p:cSld>
+    <p:spTree>
+      <p:nvGrpSpPr>
+        <p:cNvPr id="1" name="">
+          <a:extLst>
+            <a:ext uri="{FF2B5EF4-FFF2-40B4-BE49-F238E27FC236}">
               <a16:creationId xmlns:a16="http://schemas.microsoft.com/office/drawing/2014/main" id="{A1C7E835-22F1-0939-BAE4-C6D6789630D4}"/>
             </a:ext>
           </a:extLst>
@@ -11644,7 +11819,7 @@
           <a:p>
             <a:fld id="{8B4C9E33-6753-472F-9C09-83153B974C9D}" type="slidenum">
               <a:rPr lang="zh-CN" altLang="en-US" smtClean="0"/>
-              <a:t>30</a:t>
+              <a:t>31</a:t>
             </a:fld>
             <a:endParaRPr lang="zh-CN" altLang="en-US" dirty="0"/>
           </a:p>
@@ -12178,7 +12353,7 @@
 </p:sld>
 </file>
 
-<file path=ppt/slides/slide31.xml><?xml version="1.0" encoding="utf-8"?>
+<file path=ppt/slides/slide32.xml><?xml version="1.0" encoding="utf-8"?>
 <p:sld xmlns:a="http://schemas.openxmlformats.org/drawingml/2006/main" xmlns:r="http://schemas.openxmlformats.org/officeDocument/2006/relationships" xmlns:p="http://schemas.openxmlformats.org/presentationml/2006/main">
   <p:cSld>
     <p:spTree>
@@ -12306,7 +12481,7 @@
           <a:p>
             <a:fld id="{8B4C9E33-6753-472F-9C09-83153B974C9D}" type="slidenum">
               <a:rPr lang="zh-CN" altLang="en-US" smtClean="0"/>
-              <a:t>31</a:t>
+              <a:t>32</a:t>
             </a:fld>
             <a:endParaRPr lang="zh-CN" altLang="en-US"/>
           </a:p>
@@ -12416,7 +12591,7 @@
 </p:sld>
 </file>
 
-<file path=ppt/slides/slide32.xml><?xml version="1.0" encoding="utf-8"?>
+<file path=ppt/slides/slide33.xml><?xml version="1.0" encoding="utf-8"?>
 <p:sld xmlns:a="http://schemas.openxmlformats.org/drawingml/2006/main" xmlns:r="http://schemas.openxmlformats.org/officeDocument/2006/relationships" xmlns:p="http://schemas.openxmlformats.org/presentationml/2006/main">
   <p:cSld>
     <p:spTree>
@@ -12565,7 +12740,7 @@
           <a:p>
             <a:fld id="{8B4C9E33-6753-472F-9C09-83153B974C9D}" type="slidenum">
               <a:rPr lang="zh-CN" altLang="en-US" smtClean="0"/>
-              <a:t>32</a:t>
+              <a:t>33</a:t>
             </a:fld>
             <a:endParaRPr lang="zh-CN" altLang="en-US"/>
           </a:p>
@@ -12923,7 +13098,7 @@
 </p:sld>
 </file>
 
-<file path=ppt/slides/slide33.xml><?xml version="1.0" encoding="utf-8"?>
+<file path=ppt/slides/slide34.xml><?xml version="1.0" encoding="utf-8"?>
 <p:sld xmlns:a="http://schemas.openxmlformats.org/drawingml/2006/main" xmlns:r="http://schemas.openxmlformats.org/officeDocument/2006/relationships" xmlns:p="http://schemas.openxmlformats.org/presentationml/2006/main">
   <p:cSld>
     <p:spTree>
@@ -13763,13 +13938,13 @@
   <p:clrMapOvr>
     <a:masterClrMapping/>
   </p:clrMapOvr>
-  <mc:AlternateContent xmlns:mc="http://schemas.openxmlformats.org/markup-compatibility/2006">
-    <mc:Choice xmlns:p159="http://schemas.microsoft.com/office/powerpoint/2015/09/main" Requires="p159">
+  <mc:AlternateContent xmlns:mc="http://schemas.openxmlformats.org/markup-compatibility/2006" xmlns:p159="http://schemas.microsoft.com/office/powerpoint/2015/09/main">
+    <mc:Choice Requires="p159">
       <p:transition xmlns:p14="http://schemas.microsoft.com/office/powerpoint/2010/main" spd="slow" p14:dur="2000">
         <p159:morph option="byObject"/>
       </p:transition>
     </mc:Choice>
-    <mc:Fallback>
+    <mc:Fallback xmlns="">
       <p:transition spd="slow">
         <p:fade/>
       </p:transition>
@@ -14132,13 +14307,13 @@
   <p:clrMapOvr>
     <a:masterClrMapping/>
   </p:clrMapOvr>
-  <mc:AlternateContent xmlns:mc="http://schemas.openxmlformats.org/markup-compatibility/2006">
-    <mc:Choice xmlns:p159="http://schemas.microsoft.com/office/powerpoint/2015/09/main" Requires="p159">
+  <mc:AlternateContent xmlns:mc="http://schemas.openxmlformats.org/markup-compatibility/2006" xmlns:p159="http://schemas.microsoft.com/office/powerpoint/2015/09/main">
+    <mc:Choice Requires="p159">
       <p:transition xmlns:p14="http://schemas.microsoft.com/office/powerpoint/2010/main" spd="slow" p14:dur="2000">
         <p159:morph option="byObject"/>
       </p:transition>
     </mc:Choice>
-    <mc:Fallback>
+    <mc:Fallback xmlns="">
       <p:transition spd="slow">
         <p:fade/>
       </p:transition>
@@ -14733,13 +14908,13 @@
   <p:clrMapOvr>
     <a:masterClrMapping/>
   </p:clrMapOvr>
-  <mc:AlternateContent xmlns:mc="http://schemas.openxmlformats.org/markup-compatibility/2006">
-    <mc:Choice xmlns:p159="http://schemas.microsoft.com/office/powerpoint/2015/09/main" Requires="p159">
+  <mc:AlternateContent xmlns:mc="http://schemas.openxmlformats.org/markup-compatibility/2006" xmlns:p159="http://schemas.microsoft.com/office/powerpoint/2015/09/main">
+    <mc:Choice Requires="p159">
       <p:transition xmlns:p14="http://schemas.microsoft.com/office/powerpoint/2010/main" spd="slow" p14:dur="2000">
         <p159:morph option="byObject"/>
       </p:transition>
     </mc:Choice>
-    <mc:Fallback>
+    <mc:Fallback xmlns="">
       <p:transition spd="slow">
         <p:fade/>
       </p:transition>

</xml_diff>